<commit_message>
EP4: refuerza justificacion normativa en la estrategia
</commit_message>
<xml_diff>
--- a/Material y actividades en clases/Evaluacion 2/Entregables/Presentacion_EP4_Cuidarte.pptx
+++ b/Material y actividades en clases/Evaluacion 2/Entregables/Presentacion_EP4_Cuidarte.pptx
@@ -1695,8 +1695,8 @@
               <a:rPr lang="en-US" dirty="0"/>
               <a:t>01:00–02:00 · Estrategia.
 La estrategia no fue probar todo: fue ordenar por riesgo. La matriz cruza impacto y probabilidad. Los riesgos del Plan Maestro son RS-01 escalación de JWT, RS-02 fuga de datos clínicos, RS-03 lentitud por el delay de cinco segundos y RS-04 auditoría incompleta.
-Ese orden explica por qué seguridad e integridad pesan más que una cobertura funcional amplia. La ejecución combina revisión manual contra OWASP, análisis estático y evidencia reproducible en Docker con PostgreSQL.
-Pregunta probable: ¿por qué no pruebas de carga? Porque el entorno y el tiempo no permitían simular 200 usuarios con validez; se declara como trabajo futuro en vez de inventar resultados.</a:t>
+Ese orden explica por qué seguridad e integridad pesan más que una cobertura funcional amplia: Cuidarte+ trata datos sensibles de salud, y la Ley 19.628 exige confidencialidad mientras la Ley 20.584 exige control y trazabilidad de la ficha. La ejecución combina revisión manual contra OWASP, análisis estático y evidencia reproducible en Docker con PostgreSQL.
+Si preguntan por carga: no se simularon 200 usuarios; se declara como trabajo futuro, no se inventa.</a:t>
             </a:r>
             <a:endParaRPr lang="en-US" dirty="0"/>
           </a:p>

</xml_diff>

<commit_message>
EP3+EP4: correcciones segun auditoria contra pautas (portada, matriz, IE3/IE5, 5.2, slides)
Informe (EP3):
- Portada completa: seccion 003D, carrera Ingenieria en Informatica, docente Luis Yagi
- Anexo A con 6 evidencias embebidas y verificacion visual de tablas en PDF
- 3.2: columna Aplicacion + filas de tipos no aplicados (regresion, UAT,
  compatibilidad, accesibilidad, carga) con motivo; cita NFR-DIS-2 verificada contra ERS
- 5.2: columnas Incidente y Fecha y responsable (formato oficial); CP006 -> H-02
- Indice reconstruido con paginas reales del documento de 33 paginas

Presentacion (EP4):
- Correccion de errores facticos (logout/revocacion, /files/documentos, mapeo SAST)
- Guion de 9:40 min sobre 10 min permitidos y linea etico-normativa en el veredicto

🤖 Generated with Codebuff
Co-Authored-By: Codebuff <noreply@codebuff.com>
</commit_message>
<xml_diff>
--- a/Material y actividades en clases/Evaluacion 2/Entregables/Presentacion_EP4_Cuidarte.pptx
+++ b/Material y actividades en clases/Evaluacion 2/Entregables/Presentacion_EP4_Cuidarte.pptx
@@ -800,7 +800,7 @@
             <a:r>
               <a:rPr lang="en-US" dirty="0"/>
               <a:t>00:00–00:20 · Portada.
-Buenos días. Somos Benjamín Ibáñez y Gerardo Vera. Presentamos la auditoría de calidad, seguridad y cumplimiento normativo de Cuidarte+, ejecutada sobre el módulo de pacientes y los controles que protegen los datos clínicos.
+Buenos días. Somos Benjamín Ibáñez y Gerardo Vera González. Presentamos la auditoría de calidad, seguridad y cumplimiento normativo de Cuidarte+, ejecutada sobre el módulo de pacientes y los controles que protegen los datos clínicos.
 El resultado central está a la vista: ocho casos ejecutados, siete aprobados y un fallo reproducible. La línea que cruza la portada no es decorativa: es la evidencia del CP006, un token que sigue funcionando después del logout.</a:t>
             </a:r>
             <a:endParaRPr lang="en-US" dirty="0"/>
@@ -889,8 +889,8 @@
           <a:p>
             <a:r>
               <a:rPr lang="en-US" dirty="0"/>
-              <a:t>07:55–08:55 · SonarQube frente al marco legal.
-El Quality Gate está en verde. Eso suele leerse como "todo bien", pero el propio SonarQube muestra 73 issues, ocho críticos, 0,0% de cobertura y 465 minutos de deuda. Y no ve las contraseñas en texto plano ni la revocación de sesión, porque son fallos de diseño, no patrones que su motor detecte.
+              <a:t>07:10–08:00 · SonarQube frente al marco legal.
+El Quality Gate está en verde, aunque el gate no tenía condiciones configuradas: ese verde certifica que el análisis corrió, no que se superaran umbrales. Eso suele leerse como "todo bien", pero el propio SonarQube muestra 73 issues, ocho críticos, 0,0% de cobertura y 465 minutos de deuda. Y no ve las contraseñas en texto plano ni la revocación de sesión, porque son fallos de diseño, no patrones que su motor detecte.
 Por eso el slide cruza cada hallazgo con la norma: H-01 y H-02 con OWASP A02/A07 y la Ley 19.628; H-03 con la Ley 20.584; H-04 con OWASP A01 y la Ley 19.628. La ausencia de cobertura se cruza con ISO 25010.
 La frase final es la tesis: SonarQube mide patrones; la ley exige deberes.</a:t>
             </a:r>
@@ -980,7 +980,7 @@
           <a:p>
             <a:r>
               <a:rPr lang="en-US" dirty="0"/>
-              <a:t>08:55–09:40 · Reflexiones.
+              <a:t>08:00–08:50 · Reflexiones.
 Este slide separa lo que funcionó de lo que no. En calidad, RBAC, validaciones y auditoría responden; la brecha es deuda técnica: 73 issues y 14,5% de duplicación. En seguridad, JWT y roles bloquean accesos indebidos; la brecha es H-01 y CP006. En lo normativo, la auditoría y la trazabilidad existen; la Ley 19.628 se incumple en H-01, H-02 y H-04. En lo ético, reportamos el fail y declaramos lo que no probamos.
 La frase de cierre es la que quiero dejar: una auditoría se mide por lo que revela, no por lo que confirma.</a:t>
             </a:r>
@@ -1070,11 +1070,11 @@
           <a:p>
             <a:r>
               <a:rPr lang="en-US" dirty="0"/>
-              <a:t>09:40–10:00 · Veredicto y cierre de la presentación.
-El veredicto es GO CONDICIONADO. El sistema puede seguir en desarrollo y puede usarse en un entorno controlado, pero no pasa a producción con datos reales hasta corregir cuatro cosas: hash de contraseñas, revocación de JWT y secreto por entorno, validación del dígito verificador del RUT y autenticación en /uploads.
+              <a:t>08:50–09:20 · Veredicto y cierre de la presentación.
+El veredicto es GO CONDICIONADO. El sistema puede seguir en desarrollo y puede usarse en un entorno controlado, pero no pasa a producción con datos reales hasta corregir cuatro cosas: hash de contraseñas, revocación de JWT y secreto por entorno, validación del dígito verificador del RUT y autenticación en /files/documentos.
 Cada acción tiene un criterio de aceptación verificable. No decimos "mejorar la seguridad"; decimos qué se corrige y cómo se comprueba.
 Si H-01 a H-04 no se corrigen, el veredicto cambia a NO-GO. Con datos clínicos, la seguridad es un deber de cuidado, no un ítem de checklist.
-[Fin de los 10 minutos. Los anexos quedan para preguntas.]</a:t>
+[Cierre a los 09:40, con 20 segundos de margen. Los anexos quedan para preguntas.]</a:t>
             </a:r>
             <a:endParaRPr lang="en-US" dirty="0"/>
           </a:p>
@@ -1162,7 +1162,7 @@
           <a:p>
             <a:r>
               <a:rPr lang="en-US" dirty="0"/>
-              <a:t>Cierre. Agradecer y abrir preguntas. Si la pregunta es de detalle, saltar al anexo correspondiente: A casos, B SonarQube, C normativa, D evidencias.</a:t>
+              <a:t>09:20–09:40 · Cierre. Agradecer y abrir preguntas. Si la pregunta es de detalle, saltar al anexo correspondiente: A casos, B SonarQube, C normativa, D evidencias.</a:t>
             </a:r>
             <a:endParaRPr lang="en-US" dirty="0"/>
           </a:p>
@@ -1338,7 +1338,7 @@
           <a:p>
             <a:r>
               <a:rPr lang="en-US" dirty="0"/>
-              <a:t>Anexo B. Métricas completas de SonarQube y los ocho issues críticos S3776 con su complejidad. Si preguntan por qué el gate pasa con 0% de cobertura: el gate evalúa las condiciones configuradas para el proyecto, no una auditoría integral; la cobertura ausente se reporta como brecha.</a:t>
+              <a:t>Anexo B. Métricas completas de SonarQube y los ocho issues críticos S3776 con su complejidad. Si preguntan por qué el gate pasa con 0% de cobertura: el proyecto no tenía condiciones configuradas en el gate, así que el verde no equivale a una auditoría integral; la cobertura ausente se reporta como brecha.</a:t>
             </a:r>
             <a:endParaRPr lang="en-US" dirty="0"/>
           </a:p>
@@ -1602,7 +1602,7 @@
           <a:p>
             <a:r>
               <a:rPr lang="en-US" dirty="0"/>
-              <a:t>00:20–01:00 · El caso.
+              <a:t>00:20–00:55 · El caso.
 Cuidarte+ es una plataforma para centros de salud: pacientes, exámenes y documentos clínicos. No auditamos toda la plataforma: priorizamos el registro de pacientes y la cadena de controles que lo rodea.
 Los tres roles del ERS son la base del modelo de autorización: admin con acceso total, médico con información clínica y paciente solo lectura. Si un control de rol falla, falla la separación entre esos mundos.
 Dato para preguntas: el alcance se declara explícitamente para no convertir una prueba acotada en una promesa de seguridad total.</a:t>
@@ -1693,7 +1693,7 @@
           <a:p>
             <a:r>
               <a:rPr lang="en-US" dirty="0"/>
-              <a:t>01:00–02:00 · Estrategia.
+              <a:t>00:55–01:55 · Estrategia.
 La estrategia no fue probar todo: fue ordenar por riesgo. La matriz cruza impacto y probabilidad. Los riesgos del Plan Maestro son RS-01 escalación de JWT, RS-02 fuga de datos clínicos, RS-03 lentitud por el delay de cinco segundos y RS-04 auditoría incompleta.
 Ese orden explica por qué seguridad e integridad pesan más que una cobertura funcional amplia: Cuidarte+ trata datos sensibles de salud, y la Ley 19.628 exige confidencialidad mientras la Ley 20.584 exige control y trazabilidad de la ficha. La ejecución combina revisión manual contra OWASP, análisis estático y evidencia reproducible en Docker con PostgreSQL.
 Si preguntan por carga: no se simularon 200 usuarios; se declara como trabajo futuro, no se inventa.</a:t>
@@ -1784,7 +1784,7 @@
           <a:p>
             <a:r>
               <a:rPr lang="en-US" dirty="0"/>
-              <a:t>02:00–03:00 · Tipos de prueba, primera parte.
+              <a:t>01:55–02:50 · Tipos de prueba, primera parte.
 Este slide responde al 38% de la rúbrica: qué tipos se aplicaron, de dónde salen y qué impacto tienen. No elegimos técnicas al azar: cada bloque nace de un requisito y de un riesgo.
 Funcional: cuatro casos sobre el registro de pacientes, con positivo, negativo, duplicado y borde. Seguridad: tres casos sobre JWT, logout y RBAC. Integridad: un caso de carga y descarga con SHA-256. Estático: SonarQube sobre 10.133 líneas.
 La frase final es importante: no vendemos cobertura total; vendemos cobertura priorizada y declarada.</a:t>
@@ -1875,7 +1875,7 @@
           <a:p>
             <a:r>
               <a:rPr lang="en-US" dirty="0"/>
-              <a:t>03:00–04:10 · Tipos de prueba, segunda parte.
+              <a:t>02:50–03:45 · Tipos de prueba, segunda parte.
 Aquí está el impacto real de cada tipo. Funcional detecta datos inválidos antes de que lleguen a la base. Seguridad detecta que un token reutilizado sigue dando 200 y que un paciente no puede modificar un examen, que sí funciona con 403. Integridad demuestra que el archivo subido y el descargado tienen el mismo SHA-256. Estático encuentra 73 issues, ocho críticos.
 También declaro lo que no se probó: carga, usabilidad y DAST. Y lo digo con una frase que vale para toda la defensa: no probado no es aprobado.
 Pregunta probable: ¿por qué los tiempos son de cinco segundos? Por el middleware delay de cinco segundos del backend, que se aplica a pacientes, exámenes y documentos. Por eso no los uso como aprobación de rendimiento.</a:t>
@@ -1966,9 +1966,9 @@
           <a:p>
             <a:r>
               <a:rPr lang="en-US" dirty="0"/>
-              <a:t>04:10–05:00 · Trazabilidad.
-Este es el slide que responde a la cobertura: siete requisitos del ERS, ocho casos y evidencia para todos. Pero hay una distinción honesta: cuatro RQ tienen caso formal, tres se verificaron por observación, revisión de código o prueba manual.
-RQ-04, tiempos, se observa con CP007 y CP008. RQ-05, auditoría, se revisa en código y se confirma con el registro de CP001. RQ-06, RUT, se prueba manualmente y se documenta como H-03.
+              <a:t>03:45–04:30 · Trazabilidad.
+Este es el slide que responde a la cobertura: siete requisitos priorizados del ERS, ocho casos y evidencia archivada para los cuatro casos formales. Hay una distinción honesta: cuatro RQ tienen caso formal y tres se verificaron por observación, revisión de código o prueba manual.
+RQ-04, tiempos, se observa con CP007 y CP008. RQ-05, auditoría, se revisa en el código (insert en pacientes.js) y se apoya en CP001. RQ-06, RUT, se prueba manualmente y se documenta como H-03, sin captura archivada.
 Cobertura de requisitos no es cobertura de código. SonarQube marca 0,0% de cobertura automatizada y eso también es un hallazgo de calidad.</a:t>
             </a:r>
             <a:endParaRPr lang="en-US" dirty="0"/>
@@ -2057,10 +2057,10 @@
           <a:p>
             <a:r>
               <a:rPr lang="en-US" dirty="0"/>
-              <a:t>05:00–05:45 · Herramientas.
+              <a:t>04:30–05:10 · Herramientas.
 Cada herramienta tiene una función distinta. Docker Compose permite reproducir el entorno; Swagger/OpenAPI da el contrato; curl y Postman capturan la evidencia; PostgreSQL permite verificar el efecto real, por ejemplo que el intento de CP007 no cambió la base; SonarQube hace el análisis estático.
 No usamos ZAP. Lo digo antes de que lo pregunten: no se ejecutó y queda como trabajo futuro. Es más honesto declararlo que presentar un escaneo que no existe.
-Si preguntan por SonarQube: versión 9.9.8, perfil OWASP, 10.133 líneas, Quality Gate OK.</a:t>
+Si preguntan por SonarQube: versión 9.9.8, perfil OWASP, 10.133 líneas, Quality Gate OK, aunque el gate no tenía condiciones configuradas.</a:t>
             </a:r>
             <a:endParaRPr lang="en-US" dirty="0"/>
           </a:p>
@@ -2148,7 +2148,7 @@
           <a:p>
             <a:r>
               <a:rPr lang="en-US" dirty="0"/>
-              <a:t>05:45–06:40 · Ejecución.
+              <a:t>05:10–06:00 · Ejecución.
 Dos jornadas. El 6 de octubre ejecutamos CP001 a CP004: registro válido, email inválido, duplicado y borde de nombre. Cuatro pass. El 16 de octubre ejecutamos CP005 a CP008: login, reuso de token, RBAC e integridad documental, más SonarQube. Tres pass y un fail.
 La captura de la izquierda es CP003: el formulario muestra el error y la red confirma 400. La tarjeta roja es CP006: después del logout, el token anterior sigue devolviendo 200 con la lista completa de pacientes. Ese es el fallo que sostiene el veredicto condicionado.
 Pregunta probable: ¿el fail es del cliente o del servidor? Del servidor: no hay lista de revocación ni invalidación del token; el logout solo elimina el token del navegador.</a:t>
@@ -2239,9 +2239,9 @@
           <a:p>
             <a:r>
               <a:rPr lang="en-US" dirty="0"/>
-              <a:t>06:40–07:55 · Hallazgos.
+              <a:t>06:00–07:10 · Hallazgos.
 Siete hallazgos, clasificados con una escala explícita: crítico, grave, moderado y leve. El crítico es H-01: las contraseñas se guardan y comparan en texto plano en auth.js, líneas 21 y 110. Eso incumple la Ley 19.628 y OWASP A02.
-H-02 es el JWT sin revocación y con secreto por defecto; CP006 lo confirma. H-03 es el RUT sin dígito verificador: acepta 12.345.678-9 aunque el DV real es 5. H-04 es latente: express.static sirve /uploads sin autenticación.
+H-02 es el JWT sin revocación y con secreto por defecto; CP006 lo confirma. H-03 es el RUT sin dígito verificador: acepta 21.437.351-4 aunque el DV real es 3. H-04 es latente: express.static sirve /files/documentos sin autenticación.
 H-05, H-06 y H-07 son moderados y leve: delay de cinco segundos, CORS abierto y mensajes internos expuestos. La clasificación no es decorativa: define qué se corrige antes de producción.</a:t>
             </a:r>
             <a:endParaRPr lang="en-US" dirty="0"/>
@@ -2872,7 +2872,7 @@
                 <a:ea typeface="Calibri" pitchFamily="34" charset="-122"/>
                 <a:cs typeface="Calibri" pitchFamily="34" charset="-120"/>
               </a:rPr>
-              <a:t>Benjamín Ibáñez · Gerardo Vera</a:t>
+              <a:t>Benjamín Ibáñez · Gerardo Vera González</a:t>
             </a:r>
             <a:endParaRPr lang="en-US" sz="1050" dirty="0"/>
           </a:p>
@@ -7756,7 +7756,7 @@
                 <a:ea typeface="Calibri" pitchFamily="34" charset="-122"/>
                 <a:cs typeface="Calibri" pitchFamily="34" charset="-120"/>
               </a:rPr>
-              <a:t>12.345.678-9 rechazado; 12.345.678-5 aceptado.</a:t>
+              <a:t>21.437.351-4 rechazado; 21.437.351-3 aceptado.</a:t>
             </a:r>
             <a:endParaRPr lang="en-US" sz="870" dirty="0"/>
           </a:p>
@@ -7934,7 +7934,7 @@
                 <a:ea typeface="Calibri" pitchFamily="34" charset="-122"/>
                 <a:cs typeface="Calibri" pitchFamily="34" charset="-120"/>
               </a:rPr>
-              <a:t>Autenticación en /uploads</a:t>
+              <a:t>Autenticación en /files/documentos</a:t>
             </a:r>
             <a:endParaRPr lang="en-US" sz="1150" dirty="0"/>
           </a:p>
@@ -8015,7 +8015,7 @@
                 <a:ea typeface="Calibri" pitchFamily="34" charset="-122"/>
                 <a:cs typeface="Calibri" pitchFamily="34" charset="-120"/>
               </a:rPr>
-              <a:t>Con datos clínicos, la seguridad es un deber de cuidado, no un ítem de checklist.</a:t>
+              <a:t>Ley 19.628 y 20.584: con datos clínicos, la seguridad es un deber de cuidado, no un ítem de checklist.</a:t>
             </a:r>
             <a:endParaRPr lang="en-US" sz="1050" dirty="0"/>
           </a:p>
@@ -15548,25 +15548,16 @@
                     <a:bodyPr/>
                     <a:lstStyle/>
                     <a:p>
-                      <a:pPr indent="0" marL="0">
-                        <a:buNone/>
-                      </a:pPr>
+                      <a:pPr/>
                       <a:r>
-                        <a:rPr lang="en-US" sz="860" dirty="0">
+                        <a:rPr sz="860">
                           <a:solidFill>
                             <a:srgbClr val="1A2A25"/>
                           </a:solidFill>
-                          <a:latin typeface="Calibri" pitchFamily="34" charset="0"/>
-                          <a:ea typeface="Calibri" pitchFamily="34" charset="-122"/>
-                          <a:cs typeface="Calibri" pitchFamily="34" charset="-120"/>
+                          <a:latin typeface="Calibri"/>
                         </a:rPr>
-                        <a:t>H-04: /uploads sin autenticación.</a:t>
+                        <a:t>H-04: /files/documentos sin autenticación.</a:t>
                       </a:r>
-                      <a:endParaRPr lang="en-US" sz="860" dirty="0">
-                        <a:latin typeface="Calibri" charset="0"/>
-                        <a:ea typeface="Calibri" charset="0"/>
-                        <a:cs typeface="Calibri" charset="0"/>
-                      </a:endParaRPr>
                     </a:p>
                   </a:txBody>
                   <a:tcPr marL="91440" marR="91440" marT="45720" marB="45720">
@@ -22445,7 +22436,7 @@
                 <a:ea typeface="Courier New" pitchFamily="34" charset="-122"/>
                 <a:cs typeface="Courier New" pitchFamily="34" charset="-120"/>
               </a:rPr>
-              <a:t>RQ-04/05/06 · NFR-SEG-8</a:t>
+              <a:t>ISO/IEC 25010 · NFR-SEG-1…9</a:t>
             </a:r>
             <a:endParaRPr lang="en-US" sz="730" dirty="0"/>
           </a:p>
@@ -24709,7 +24700,7 @@
                 <a:ea typeface="Cambria" pitchFamily="34" charset="-122"/>
                 <a:cs typeface="Cambria" pitchFamily="34" charset="-120"/>
               </a:rPr>
-              <a:t>Siete requisitos, ocho casos: cobertura completa con distinto nivel de evidencia</a:t>
+              <a:t>Siete requisitos priorizados, ocho casos: cobertura completa con distinto nivel de evidencia</a:t>
             </a:r>
             <a:endParaRPr lang="en-US" sz="2400" dirty="0"/>
           </a:p>
@@ -26333,25 +26324,16 @@
                     <a:bodyPr/>
                     <a:lstStyle/>
                     <a:p>
-                      <a:pPr indent="0" marL="0">
-                        <a:buNone/>
-                      </a:pPr>
+                      <a:pPr/>
                       <a:r>
-                        <a:rPr lang="en-US" sz="840" dirty="0">
+                        <a:rPr sz="840">
                           <a:solidFill>
                             <a:srgbClr val="1A2A25"/>
                           </a:solidFill>
-                          <a:latin typeface="Calibri" pitchFamily="34" charset="0"/>
-                          <a:ea typeface="Calibri" pitchFamily="34" charset="-122"/>
-                          <a:cs typeface="Calibri" pitchFamily="34" charset="-120"/>
+                          <a:latin typeface="Calibri"/>
                         </a:rPr>
-                        <a:t>Revisión + caso · CP001</a:t>
+                        <a:t>Revisión + CP001</a:t>
                       </a:r>
-                      <a:endParaRPr lang="en-US" sz="840" dirty="0">
-                        <a:latin typeface="Calibri" charset="0"/>
-                        <a:ea typeface="Calibri" charset="0"/>
-                        <a:cs typeface="Calibri" charset="0"/>
-                      </a:endParaRPr>
                     </a:p>
                   </a:txBody>
                   <a:tcPr marL="91440" marR="91440" marT="45720" marB="45720">
@@ -26607,25 +26589,16 @@
                     <a:bodyPr/>
                     <a:lstStyle/>
                     <a:p>
-                      <a:pPr indent="0" marL="0">
-                        <a:buNone/>
-                      </a:pPr>
+                      <a:pPr/>
                       <a:r>
-                        <a:rPr lang="en-US" sz="840" dirty="0">
+                        <a:rPr sz="840">
                           <a:solidFill>
                             <a:srgbClr val="1A2A25"/>
                           </a:solidFill>
-                          <a:latin typeface="Calibri" pitchFamily="34" charset="0"/>
-                          <a:ea typeface="Calibri" pitchFamily="34" charset="-122"/>
-                          <a:cs typeface="Calibri" pitchFamily="34" charset="-120"/>
+                          <a:latin typeface="Calibri"/>
                         </a:rPr>
                         <a:t>Prueba manual · H-03</a:t>
                       </a:r>
-                      <a:endParaRPr lang="en-US" sz="840" dirty="0">
-                        <a:latin typeface="Calibri" charset="0"/>
-                        <a:ea typeface="Calibri" charset="0"/>
-                        <a:cs typeface="Calibri" charset="0"/>
-                      </a:endParaRPr>
                     </a:p>
                   </a:txBody>
                   <a:tcPr marL="91440" marR="91440" marT="45720" marB="45720">
@@ -27314,7 +27287,7 @@
                 <a:ea typeface="Cambria" pitchFamily="34" charset="-122"/>
                 <a:cs typeface="Cambria" pitchFamily="34" charset="-120"/>
               </a:rPr>
-              <a:t>100%</a:t>
+              <a:t>7/7</a:t>
             </a:r>
             <a:endParaRPr lang="en-US" sz="2400" dirty="0"/>
           </a:p>
@@ -27356,7 +27329,7 @@
                 <a:ea typeface="Calibri" pitchFamily="34" charset="-122"/>
                 <a:cs typeface="Calibri" pitchFamily="34" charset="-120"/>
               </a:rPr>
-              <a:t>RQ con evidencia</a:t>
+              <a:t>RQ cubiertos</a:t>
             </a:r>
             <a:endParaRPr lang="en-US" sz="860" dirty="0"/>
           </a:p>
@@ -27527,7 +27500,7 @@
                 <a:ea typeface="Calibri" pitchFamily="34" charset="-122"/>
                 <a:cs typeface="Calibri" pitchFamily="34" charset="-120"/>
               </a:rPr>
-              <a:t>Los RQ sin caso formal no se declaran probados: se verificaron por observación, revisión de código o prueba manual.</a:t>
+              <a:t>Los RQ sin caso formal se verificaron por revisión de código o prueba manual: RQ-05 con CP001 y RQ-06 sin captura archivada.</a:t>
             </a:r>
             <a:endParaRPr lang="en-US" sz="900" dirty="0"/>
           </a:p>
@@ -29767,7 +29740,7 @@
               <a:buNone/>
             </a:pPr>
             <a:r>
-              <a:rPr lang="en-US" sz="740" spc="20" kern="0" dirty="0">
+              <a:rPr lang="en-US" sz="640" spc="20" kern="0" dirty="0">
                 <a:solidFill>
                   <a:srgbClr val="B23A2F"/>
                 </a:solidFill>
@@ -29775,7 +29748,7 @@
                 <a:ea typeface="Courier New" pitchFamily="34" charset="-122"/>
                 <a:cs typeface="Courier New" pitchFamily="34" charset="-120"/>
               </a:rPr>
-              <a:t>POST /logout → 200   ·   GET /pacientes con el token previo → 200   ·   esperado: 401</a:t>
+              <a:t>Sin endpoint de logout · token previo aceptado (200) · esperado: 401</a:t>
             </a:r>
             <a:endParaRPr lang="en-US" sz="740" dirty="0"/>
           </a:p>
@@ -29817,7 +29790,7 @@
                 <a:ea typeface="Calibri" pitchFamily="34" charset="-122"/>
                 <a:cs typeface="Calibri" pitchFamily="34" charset="-120"/>
               </a:rPr>
-              <a:t>La sesión se cierra en el cliente, pero el token sigue siendo aceptado por el servidor.</a:t>
+              <a:t>El cierre de sesión solo borra el token en el navegador; el servidor lo sigue aceptando.</a:t>
             </a:r>
             <a:endParaRPr lang="en-US" sz="880" dirty="0"/>
           </a:p>
@@ -31166,7 +31139,7 @@
                 <a:ea typeface="Calibri" pitchFamily="34" charset="-122"/>
                 <a:cs typeface="Calibri" pitchFamily="34" charset="-120"/>
               </a:rPr>
-              <a:t>Acepta 12.345.678-9; el dígito real es 5.</a:t>
+              <a:t>Acepta 21.437.351-4; el dígito real es 3.</a:t>
             </a:r>
             <a:endParaRPr lang="en-US" sz="860" dirty="0"/>
           </a:p>
@@ -31356,7 +31329,7 @@
                 <a:ea typeface="Calibri" pitchFamily="34" charset="-122"/>
                 <a:cs typeface="Calibri" pitchFamily="34" charset="-120"/>
               </a:rPr>
-              <a:t>Cualquiera que conozca la URL accede a un documento clínico.</a:t>
+              <a:t>Si se almacenaran en disco, cualquiera con la URL accedería sin sesión.</a:t>
             </a:r>
             <a:endParaRPr lang="en-US" sz="860" dirty="0"/>
           </a:p>

</xml_diff>

<commit_message>
EP4: refleja las 25 incidencias SonarQube del informe en los slides 10 y 15
Slide 10: nota al pie en la tarjeta del grafico que remite a la secc. 5.4
y Anexo B del informe. Slide 15: tabla de criticas con IDs SQ del informe
(top 3 destacado: SQ-08·39, SQ-06·33, SQ-04·27), epigrafe actualizado y
mencion de las 25 priorizadas documentadas. Punteros en notas del orador
para ofrecer el informe si el profesor pide detalle. PDF regenerado y
verificado visualmente.

🤖 Generated with Codebuff
Co-Authored-By: Codebuff <noreply@codebuff.com>
</commit_message>
<xml_diff>
--- a/Material y actividades en clases/Evaluacion 2/Entregables/Presentacion_EP4_Cuidarte.pptx
+++ b/Material y actividades en clases/Evaluacion 2/Entregables/Presentacion_EP4_Cuidarte.pptx
@@ -888,13 +888,32 @@
           <a:lstStyle/>
           <a:p>
             <a:r>
-              <a:rPr lang="en-US" dirty="0"/>
-              <a:t>07:10–08:00 · SonarQube frente al marco legal.
-El Quality Gate está en verde, aunque el gate no tenía condiciones configuradas: ese verde certifica que el análisis corrió, no que se superaran umbrales. Eso suele leerse como "todo bien", pero el propio SonarQube muestra 73 issues, ocho críticos, 0,0% de cobertura y 465 minutos de deuda. Y no ve las contraseñas en texto plano ni la revocación de sesión, porque son fallos de diseño, no patrones que su motor detecte.
-Por eso el slide cruza cada hallazgo con la norma: H-01 y H-02 con OWASP A02/A07 y la Ley 19.628; H-03 con la Ley 20.584; H-04 con OWASP A01 y la Ley 19.628. La ausencia de cobertura se cruza con ISO 25010.
-La frase final es la tesis: SonarQube mide patrones; la ley exige deberes.</a:t>
-            </a:r>
-            <a:endParaRPr lang="en-US" dirty="0"/>
+              <a:t>07:10–08:00 · SonarQube frente al marco legal.</a:t>
+            </a:r>
+          </a:p>
+          <a:p/>
+          <a:p>
+            <a:r>
+              <a:t>El Quality Gate está en verde, aunque el gate no tenía condiciones configuradas: ese verde certifica que el análisis corrió, no que se superaran umbrales. Eso suele leerse como "todo bien", pero el propio SonarQube muestra 73 issues, ocho críticos, 0,0% de cobertura y 465 minutos de deuda. Y no ve las contraseñas en texto plano ni la revocación de sesión, porque son fallos de diseño, no patrones que su motor detecte.</a:t>
+            </a:r>
+          </a:p>
+          <a:p/>
+          <a:p>
+            <a:r>
+              <a:t>Por eso el slide cruza cada hallazgo con la norma: H-01 y H-02 con OWASP A02/A07 y la Ley 19.628; H-03 con la Ley 20.584; H-04 con OWASP A01 y la Ley 19.628. La ausencia de cobertura se cruza con ISO 25010.</a:t>
+            </a:r>
+          </a:p>
+          <a:p/>
+          <a:p>
+            <a:r>
+              <a:t>La frase final es la tesis: SonarQube mide patrones; la ley exige deberes.</a:t>
+            </a:r>
+          </a:p>
+          <a:p/>
+          <a:p>
+            <a:r>
+              <a:t>PUNTERO (no leer completo): las 25 incidencias priorizadas (SQ-01 a SQ-25) están en la secc. 5.4 y el Anexo B del informe; mencionar la cifra y ofrecer el informe si se pide detalle; solo nombrar top 3 si preguntan.</a:t>
+            </a:r>
           </a:p>
         </p:txBody>
       </p:sp>
@@ -1337,10 +1356,14 @@
           <a:lstStyle/>
           <a:p>
             <a:r>
-              <a:rPr lang="en-US" dirty="0"/>
               <a:t>Anexo B. Métricas completas de SonarQube y los ocho issues críticos S3776 con su complejidad. Si preguntan por qué el gate pasa con 0% de cobertura: el proyecto no tenía condiciones configuradas en el gate, así que el verde no equivale a una auditoría integral; la cobertura ausente se reporta como brecha.</a:t>
             </a:r>
-            <a:endParaRPr lang="en-US" dirty="0"/>
+          </a:p>
+          <a:p/>
+          <a:p>
+            <a:r>
+              <a:t>PUNTERO: la tabla muestra solo las 8 críticas con su ID SQ del informe; el resto de las 25 priorizadas está fichado en el Anexo B del informe (código y JSON). Detalle completo de las 73 en Grupo1_SonarQube_issues.json.</a:t>
+            </a:r>
           </a:p>
         </p:txBody>
       </p:sp>
@@ -3231,6 +3254,10 @@
             <a:prstDash val="solid"/>
           </a:ln>
         </p:spPr>
+        <p:txBody>
+          <a:bodyPr/>
+          <a:p/>
+        </p:txBody>
       </p:sp>
       <p:sp>
         <p:nvSpPr>
@@ -3424,6 +3451,10 @@
             </a:outerShdw>
           </a:effectLst>
         </p:spPr>
+        <p:txBody>
+          <a:bodyPr/>
+          <a:p/>
+        </p:txBody>
       </p:sp>
       <p:sp>
         <p:nvSpPr>
@@ -3536,6 +3567,10 @@
             </a:outerShdw>
           </a:effectLst>
         </p:spPr>
+        <p:txBody>
+          <a:bodyPr/>
+          <a:p/>
+        </p:txBody>
       </p:sp>
       <p:sp>
         <p:nvSpPr>
@@ -3648,6 +3683,10 @@
             </a:outerShdw>
           </a:effectLst>
         </p:spPr>
+        <p:txBody>
+          <a:bodyPr/>
+          <a:p/>
+        </p:txBody>
       </p:sp>
       <p:sp>
         <p:nvSpPr>
@@ -3760,6 +3799,10 @@
             </a:outerShdw>
           </a:effectLst>
         </p:spPr>
+        <p:txBody>
+          <a:bodyPr/>
+          <a:p/>
+        </p:txBody>
       </p:sp>
       <p:sp>
         <p:nvSpPr>
@@ -3872,6 +3915,10 @@
             </a:outerShdw>
           </a:effectLst>
         </p:spPr>
+        <p:txBody>
+          <a:bodyPr/>
+          <a:p/>
+        </p:txBody>
       </p:sp>
       <p:sp>
         <p:nvSpPr>
@@ -3984,6 +4031,10 @@
             </a:outerShdw>
           </a:effectLst>
         </p:spPr>
+        <p:txBody>
+          <a:bodyPr/>
+          <a:p/>
+        </p:txBody>
       </p:sp>
       <p:sp>
         <p:nvSpPr>
@@ -4096,6 +4147,10 @@
             </a:outerShdw>
           </a:effectLst>
         </p:spPr>
+        <p:txBody>
+          <a:bodyPr/>
+          <a:p/>
+        </p:txBody>
       </p:sp>
       <p:sp>
         <p:nvSpPr>
@@ -5252,6 +5307,40 @@
           </a:p>
         </p:txBody>
       </p:sp>
+      <p:sp>
+        <p:nvSpPr>
+          <p:cNvPr id="30" name="TextBox 29"/>
+          <p:cNvSpPr txBox="1"/>
+          <p:nvPr/>
+        </p:nvSpPr>
+        <p:spPr>
+          <a:xfrm>
+            <a:off x="6510528" y="3712463"/>
+            <a:ext cx="4983480" cy="201168"/>
+          </a:xfrm>
+          <a:prstGeom prst="rect">
+            <a:avLst/>
+          </a:prstGeom>
+          <a:noFill/>
+        </p:spPr>
+        <p:txBody>
+          <a:bodyPr wrap="none">
+            <a:spAutoFit/>
+          </a:bodyPr>
+          <a:lstStyle/>
+          <a:p>
+            <a:r>
+              <a:rPr sz="710" b="1">
+                <a:solidFill>
+                  <a:srgbClr val="5C6D67"/>
+                </a:solidFill>
+                <a:latin typeface="Courier New"/>
+              </a:rPr>
+              <a:t>25 PRIORIZADAS · FICHAS EN SECC. 5.4 + ANEXO B DEL INFORME</a:t>
+            </a:r>
+          </a:p>
+        </p:txBody>
+      </p:sp>
     </p:spTree>
   </p:cSld>
   <p:clrMapOvr>
@@ -11820,6 +11909,10 @@
             <a:prstDash val="solid"/>
           </a:ln>
         </p:spPr>
+        <p:txBody>
+          <a:bodyPr/>
+          <a:p/>
+        </p:txBody>
       </p:sp>
       <p:sp>
         <p:nvSpPr>
@@ -13374,7 +13467,7 @@
                           <a:ea typeface="Courier New" pitchFamily="34" charset="-122"/>
                           <a:cs typeface="Courier New" pitchFamily="34" charset="-120"/>
                         </a:rPr>
-                        <a:t>UsuarioForm.jsx:173</a:t>
+                        <a:t>SQ-08 · UsuarioForm.jsx:173</a:t>
                       </a:r>
                       <a:endParaRPr lang="en-US" sz="840" dirty="0">
                         <a:latin typeface="Courier New" charset="0"/>
@@ -13512,7 +13605,7 @@
                           <a:ea typeface="Courier New" pitchFamily="34" charset="-122"/>
                           <a:cs typeface="Courier New" pitchFamily="34" charset="-120"/>
                         </a:rPr>
-                        <a:t>ExamenForm.jsx:47</a:t>
+                        <a:t>SQ-06 · ExamenForm.jsx:47</a:t>
                       </a:r>
                       <a:endParaRPr lang="en-US" sz="840" dirty="0">
                         <a:latin typeface="Courier New" charset="0"/>
@@ -13650,7 +13743,7 @@
                           <a:ea typeface="Courier New" pitchFamily="34" charset="-122"/>
                           <a:cs typeface="Courier New" pitchFamily="34" charset="-120"/>
                         </a:rPr>
-                        <a:t>users.js:283</a:t>
+                        <a:t>SQ-04 · users.js:283</a:t>
                       </a:r>
                       <a:endParaRPr lang="en-US" sz="840" dirty="0">
                         <a:latin typeface="Courier New" charset="0"/>
@@ -13788,7 +13881,7 @@
                           <a:ea typeface="Courier New" pitchFamily="34" charset="-122"/>
                           <a:cs typeface="Courier New" pitchFamily="34" charset="-120"/>
                         </a:rPr>
-                        <a:t>users.js:437</a:t>
+                        <a:t>SQ-05 · users.js:437</a:t>
                       </a:r>
                       <a:endParaRPr lang="en-US" sz="840" dirty="0">
                         <a:latin typeface="Courier New" charset="0"/>
@@ -13926,7 +14019,7 @@
                           <a:ea typeface="Courier New" pitchFamily="34" charset="-122"/>
                           <a:cs typeface="Courier New" pitchFamily="34" charset="-120"/>
                         </a:rPr>
-                        <a:t>PacienteForm.jsx:21</a:t>
+                        <a:t>SQ-07 · PacienteForm.jsx:21</a:t>
                       </a:r>
                       <a:endParaRPr lang="en-US" sz="840" dirty="0">
                         <a:latin typeface="Courier New" charset="0"/>
@@ -14064,7 +14157,7 @@
                           <a:ea typeface="Courier New" pitchFamily="34" charset="-122"/>
                           <a:cs typeface="Courier New" pitchFamily="34" charset="-120"/>
                         </a:rPr>
-                        <a:t>pacientes.js:48</a:t>
+                        <a:t>SQ-02 · pacientes.js:48</a:t>
                       </a:r>
                       <a:endParaRPr lang="en-US" sz="840" dirty="0">
                         <a:latin typeface="Courier New" charset="0"/>
@@ -14202,7 +14295,7 @@
                           <a:ea typeface="Courier New" pitchFamily="34" charset="-122"/>
                           <a:cs typeface="Courier New" pitchFamily="34" charset="-120"/>
                         </a:rPr>
-                        <a:t>pacientes.js:276</a:t>
+                        <a:t>SQ-03 · pacientes.js:276</a:t>
                       </a:r>
                       <a:endParaRPr lang="en-US" sz="840" dirty="0">
                         <a:latin typeface="Courier New" charset="0"/>
@@ -14340,7 +14433,7 @@
                           <a:ea typeface="Courier New" pitchFamily="34" charset="-122"/>
                           <a:cs typeface="Courier New" pitchFamily="34" charset="-120"/>
                         </a:rPr>
-                        <a:t>auth.js:71</a:t>
+                        <a:t>SQ-01 · auth.js:71</a:t>
                       </a:r>
                       <a:endParaRPr lang="en-US" sz="840" dirty="0">
                         <a:latin typeface="Courier New" charset="0"/>
@@ -14497,7 +14590,7 @@
                 <a:ea typeface="Calibri" pitchFamily="34" charset="-122"/>
                 <a:cs typeface="Calibri" pitchFamily="34" charset="-120"/>
               </a:rPr>
-              <a:t>Los ocho issues críticos son S3776: complejidad cognitiva alta.</a:t>
+              <a:t>Los ocho críticos (SQ-01 a SQ-08) son S3776: complejidad cognitiva alta. Top 3: SQ-08 (39), SQ-06 (33), SQ-04 (27).</a:t>
             </a:r>
             <a:endParaRPr lang="en-US" sz="900" dirty="0"/>
           </a:p>
@@ -14542,6 +14635,40 @@
               <a:t>El Quality Gate evalúa las condiciones configuradas; no equivale a una auditoría de seguridad.</a:t>
             </a:r>
             <a:endParaRPr lang="en-US" sz="900" dirty="0"/>
+          </a:p>
+        </p:txBody>
+      </p:sp>
+      <p:sp>
+        <p:nvSpPr>
+          <p:cNvPr id="32" name="TextBox 31"/>
+          <p:cNvSpPr txBox="1"/>
+          <p:nvPr/>
+        </p:nvSpPr>
+        <p:spPr>
+          <a:xfrm>
+            <a:off x="566928" y="5577840"/>
+            <a:ext cx="4617720" cy="685800"/>
+          </a:xfrm>
+          <a:prstGeom prst="rect">
+            <a:avLst/>
+          </a:prstGeom>
+          <a:noFill/>
+        </p:spPr>
+        <p:txBody>
+          <a:bodyPr wrap="square">
+            <a:spAutoFit/>
+          </a:bodyPr>
+          <a:lstStyle/>
+          <a:p>
+            <a:r>
+              <a:rPr sz="900">
+                <a:solidFill>
+                  <a:srgbClr val="5C6D67"/>
+                </a:solidFill>
+                <a:latin typeface="Calibri"/>
+              </a:rPr>
+              <a:t>Las 25 incidencias priorizadas (SQ-01 a SQ-25) están documentadas en la sección 5.4 y el Anexo B del informe, con explicación en español, código real y JSON.</a:t>
+            </a:r>
           </a:p>
         </p:txBody>
       </p:sp>

</xml_diff>